<commit_message>
Fix save error, timer display, title alignment, attendee text
Fixes:
- Save Changes error: added null safety to migrateQuestions()
  and proper error handling for non-ok server responses
- Relaxed slide validation: title auto-defaults to 'Untitled'
  if missing, only id and type are required
- Timer: changed background circle stroke to transparent
  (rgba) so it blends with the template background instead
  of showing a visible square border
- Title slide: repositioned title text to align with the
  white rectangle area of the cover template background,
  logo stays top-left matching template coordinates
- Attendee text display: changed content rendering to ALWAYS
  show slide.content (markdown) regardless of whether elements
  array exists. Images/videos from elements render inline
  below text instead of using absolute positioning that could
  push content off-screen

Co-Authored-By: Claude Opus 4.6 (1M context) <noreply@anthropic.com>
</commit_message>
<xml_diff>
--- a/docs/Template_PowerPoint.pptx
+++ b/docs/Template_PowerPoint.pptx
@@ -128,11 +128,26 @@
 <pc:chgInfo xmlns:a="http://schemas.openxmlformats.org/drawingml/2006/main" xmlns:r="http://schemas.openxmlformats.org/officeDocument/2006/relationships" xmlns:ac="http://schemas.microsoft.com/office/drawing/2013/main/command" xmlns:pc="http://schemas.microsoft.com/office/powerpoint/2013/main/command">
   <pc:docChgLst>
     <pc:chgData name="Jose M Gonzalez" userId="eaa095ca649ea80c" providerId="LiveId" clId="{E61B6003-462C-404B-B2BC-5F029EC988DA}"/>
-    <pc:docChg chg="addSld">
-      <pc:chgData name="Jose M Gonzalez" userId="eaa095ca649ea80c" providerId="LiveId" clId="{E61B6003-462C-404B-B2BC-5F029EC988DA}" dt="2026-03-26T20:26:05.681" v="0" actId="680"/>
+    <pc:docChg chg="addSld modSld">
+      <pc:chgData name="Jose M Gonzalez" userId="eaa095ca649ea80c" providerId="LiveId" clId="{E61B6003-462C-404B-B2BC-5F029EC988DA}" dt="2026-03-26T21:01:33.578" v="8" actId="20577"/>
       <pc:docMkLst>
         <pc:docMk/>
       </pc:docMkLst>
+      <pc:sldChg chg="modSp mod">
+        <pc:chgData name="Jose M Gonzalez" userId="eaa095ca649ea80c" providerId="LiveId" clId="{E61B6003-462C-404B-B2BC-5F029EC988DA}" dt="2026-03-26T21:01:33.578" v="8" actId="20577"/>
+        <pc:sldMkLst>
+          <pc:docMk/>
+          <pc:sldMk cId="1101928929" sldId="277"/>
+        </pc:sldMkLst>
+        <pc:spChg chg="mod">
+          <ac:chgData name="Jose M Gonzalez" userId="eaa095ca649ea80c" providerId="LiveId" clId="{E61B6003-462C-404B-B2BC-5F029EC988DA}" dt="2026-03-26T21:01:33.578" v="8" actId="20577"/>
+          <ac:spMkLst>
+            <pc:docMk/>
+            <pc:sldMk cId="1101928929" sldId="277"/>
+            <ac:spMk id="2" creationId="{6FD936D1-4C2B-4F58-A8F0-F1683CE6DB17}"/>
+          </ac:spMkLst>
+        </pc:spChg>
+      </pc:sldChg>
       <pc:sldChg chg="new">
         <pc:chgData name="Jose M Gonzalez" userId="eaa095ca649ea80c" providerId="LiveId" clId="{E61B6003-462C-404B-B2BC-5F029EC988DA}" dt="2026-03-26T20:26:05.681" v="0" actId="680"/>
         <pc:sldMkLst>
@@ -4891,7 +4906,11 @@
           <a:bodyPr/>
           <a:lstStyle/>
           <a:p>
-            <a:endParaRPr lang="en-BE"/>
+            <a:r>
+              <a:rPr lang="es-ES" dirty="0"/>
+              <a:t>PEDRRA</a:t>
+            </a:r>
+            <a:endParaRPr lang="en-BE" dirty="0"/>
           </a:p>
         </p:txBody>
       </p:sp>

</xml_diff>